<commit_message>
laadplan: Lommel (kaart + presentatie)
</commit_message>
<xml_diff>
--- a/Fluctus_Laadplan_Lommel.pptx
+++ b/Fluctus_Laadplan_Lommel.pptx
@@ -118,7 +118,7 @@
 </p:presentation>
 </file>
 
-<file path=ppt/charts/chart1.xml><?xml version="1.0" encoding="utf-8"?>
+<file path=ppt/charts/chart3.xml><?xml version="1.0" encoding="utf-8"?>
 <c:chartSpace xmlns:c="http://schemas.openxmlformats.org/drawingml/2006/chart" xmlns:a="http://schemas.openxmlformats.org/drawingml/2006/main" xmlns:r="http://schemas.openxmlformats.org/officeDocument/2006/relationships">
   <c:date1904 val="0"/>
   <c:roundedCorners val="1"/>
@@ -7677,7 +7677,7 @@
                 <a:ea typeface="Arial" pitchFamily="34" charset="-122"/>
                 <a:cs typeface="Arial" pitchFamily="34" charset="-120"/>
               </a:rPr>
-              <a:t>De 2.300 wagens zijn de </a:t>
+              <a:t>De 7.647 wagens zijn de </a:t>
             </a:r>
             <a:pPr indent="0" marL="0">
               <a:buNone/>
@@ -7696,6 +7696,17 @@
             <a:pPr indent="0" marL="0">
               <a:buNone/>
             </a:pPr>
+            <a:r>
+              <a:rPr lang="en-US" sz="1500" dirty="0">
+                <a:solidFill>
+                  <a:srgbClr val="1A1A1A"/>
+                </a:solidFill>
+                <a:latin typeface="Arial" pitchFamily="34" charset="0"/>
+                <a:ea typeface="Arial" pitchFamily="34" charset="-122"/>
+                <a:cs typeface="Arial" pitchFamily="34" charset="-120"/>
+              </a:rPr>
+              <a:t> (de gemeente zelf + 54 parkings in de band van ±2 km rond de grens)</a:t>
+            </a:r>
             <a:pPr indent="0" marL="0">
               <a:buNone/>
             </a:pPr>
@@ -7837,7 +7848,7 @@
                 <a:ea typeface="Arial" pitchFamily="34" charset="-122"/>
                 <a:cs typeface="Arial" pitchFamily="34" charset="-120"/>
               </a:rPr>
-              <a:t>2.300</a:t>
+              <a:t>7.647</a:t>
             </a:r>
             <a:endParaRPr lang="en-US" sz="3200" dirty="0"/>
           </a:p>
@@ -7949,7 +7960,7 @@
                 <a:ea typeface="Arial" pitchFamily="34" charset="-122"/>
                 <a:cs typeface="Arial" pitchFamily="34" charset="-120"/>
               </a:rPr>
-              <a:t>43</a:t>
+              <a:t>241</a:t>
             </a:r>
             <a:endParaRPr lang="en-US" sz="3200" dirty="0"/>
           </a:p>
@@ -8061,7 +8072,7 @@
                 <a:ea typeface="Arial" pitchFamily="34" charset="-122"/>
                 <a:cs typeface="Arial" pitchFamily="34" charset="-120"/>
               </a:rPr>
-              <a:t>€ 3,45 mln</a:t>
+              <a:t>€ 11,47 mln</a:t>
             </a:r>
             <a:endParaRPr lang="en-US" sz="3200" dirty="0"/>
           </a:p>
@@ -8173,7 +8184,7 @@
                 <a:ea typeface="Arial" pitchFamily="34" charset="-122"/>
                 <a:cs typeface="Arial" pitchFamily="34" charset="-120"/>
               </a:rPr>
-              <a:t>€ 6,90 mln</a:t>
+              <a:t>€ 22,94 mln</a:t>
             </a:r>
             <a:endParaRPr lang="en-US" sz="3200" dirty="0"/>
           </a:p>
@@ -8280,7 +8291,7 @@
                 <a:ea typeface="Arial" pitchFamily="34" charset="-122"/>
                 <a:cs typeface="Arial" pitchFamily="34" charset="-120"/>
               </a:rPr>
-              <a:t>2.300 wagens</a:t>
+              <a:t>7.647 wagens</a:t>
             </a:r>
             <a:pPr indent="0" marL="0">
               <a:buNone/>
@@ -8308,7 +8319,7 @@
                 <a:ea typeface="Arial" pitchFamily="34" charset="-122"/>
                 <a:cs typeface="Arial" pitchFamily="34" charset="-120"/>
               </a:rPr>
-              <a:t>€ 3,45 mln besparing / jaar</a:t>
+              <a:t>€ 11,47 mln besparing / jaar</a:t>
             </a:r>
             <a:endParaRPr lang="en-US" sz="1500" dirty="0"/>
           </a:p>
@@ -8347,7 +8358,7 @@
                 <a:ea typeface="Arial" pitchFamily="34" charset="-122"/>
                 <a:cs typeface="Arial" pitchFamily="34" charset="-120"/>
               </a:rPr>
-              <a:t>2.300 wagens</a:t>
+              <a:t>7.647 wagens</a:t>
             </a:r>
             <a:pPr indent="0" marL="0">
               <a:buNone/>
@@ -8375,7 +8386,7 @@
                 <a:ea typeface="Arial" pitchFamily="34" charset="-122"/>
                 <a:cs typeface="Arial" pitchFamily="34" charset="-120"/>
               </a:rPr>
-              <a:t>€ 6,90 mln investering</a:t>
+              <a:t>€ 22,94 mln investering</a:t>
             </a:r>
             <a:pPr indent="0" marL="0">
               <a:buNone/>
@@ -8721,7 +8732,7 @@
                 <a:ea typeface="Arial" pitchFamily="34" charset="-122"/>
                 <a:cs typeface="Arial" pitchFamily="34" charset="-120"/>
               </a:rPr>
-              <a:t>43 parkings · 2.300 plaatsen</a:t>
+              <a:t>241 parkings · 7.647 plaatsen</a:t>
             </a:r>
             <a:endParaRPr lang="en-US" sz="2200" dirty="0"/>
           </a:p>
@@ -10776,7 +10787,7 @@
                 <a:ea typeface="Arial" pitchFamily="34" charset="-122"/>
                 <a:cs typeface="Arial" pitchFamily="34" charset="-120"/>
               </a:rPr>
-              <a:t>2.300 auto’s op 43 slimme parkings in Lommel </a:t>
+              <a:t>5.543 auto’s op 187 slimme parkings in Lommel </a:t>
             </a:r>
             <a:pPr indent="0" marL="0">
               <a:lnSpc>

</xml_diff>

<commit_message>
batch: 2/2 gemeenten (finale)
</commit_message>
<xml_diff>
--- a/Fluctus_Laadplan_Lommel.pptx
+++ b/Fluctus_Laadplan_Lommel.pptx
@@ -118,7 +118,7 @@
 </p:presentation>
 </file>
 
-<file path=ppt/charts/chart4.xml><?xml version="1.0" encoding="utf-8"?>
+<file path=ppt/charts/chart1.xml><?xml version="1.0" encoding="utf-8"?>
 <c:chartSpace xmlns:c="http://schemas.openxmlformats.org/drawingml/2006/chart" xmlns:a="http://schemas.openxmlformats.org/drawingml/2006/main" xmlns:r="http://schemas.openxmlformats.org/officeDocument/2006/relationships">
   <c:date1904 val="0"/>
   <c:roundedCorners val="1"/>
@@ -220,10 +220,10 @@
                 <c:formatCode>General</c:formatCode>
                 <c:ptCount val="2"/>
                 <c:pt idx="0">
-                  <c:v>33</c:v>
+                  <c:v>32</c:v>
                 </c:pt>
                 <c:pt idx="1">
-                  <c:v>64</c:v>
+                  <c:v>32</c:v>
                 </c:pt>
               </c:numCache>
             </c:numRef>
@@ -304,7 +304,7 @@
         <c:axId val="2094734552"/>
         <c:scaling>
           <c:orientation val="minMax"/>
-          <c:max val="80"/>
+          <c:max val="50"/>
           <c:min val="0"/>
         </c:scaling>
         <c:delete val="0"/>
@@ -3707,7 +3707,7 @@
                 <a:ea typeface="Arial" pitchFamily="34" charset="-122"/>
                 <a:cs typeface="Arial" pitchFamily="34" charset="-120"/>
               </a:rPr>
-              <a:t>+94% meer energie</a:t>
+              <a:t>+0% meer energie</a:t>
             </a:r>
             <a:pPr indent="0" marL="0">
               <a:lnSpc>
@@ -7677,7 +7677,7 @@
                 <a:ea typeface="Arial" pitchFamily="34" charset="-122"/>
                 <a:cs typeface="Arial" pitchFamily="34" charset="-120"/>
               </a:rPr>
-              <a:t>De 5.977 wagens zijn de </a:t>
+              <a:t>De 0 wagens zijn de </a:t>
             </a:r>
             <a:pPr indent="0" marL="0">
               <a:buNone/>
@@ -7837,7 +7837,7 @@
                 <a:ea typeface="Arial" pitchFamily="34" charset="-122"/>
                 <a:cs typeface="Arial" pitchFamily="34" charset="-120"/>
               </a:rPr>
-              <a:t>5.977</a:t>
+              <a:t>0</a:t>
             </a:r>
             <a:endParaRPr lang="en-US" sz="3200" dirty="0"/>
           </a:p>
@@ -7949,7 +7949,7 @@
                 <a:ea typeface="Arial" pitchFamily="34" charset="-122"/>
                 <a:cs typeface="Arial" pitchFamily="34" charset="-120"/>
               </a:rPr>
-              <a:t>210</a:t>
+              <a:t>0</a:t>
             </a:r>
             <a:endParaRPr lang="en-US" sz="3200" dirty="0"/>
           </a:p>
@@ -8061,7 +8061,7 @@
                 <a:ea typeface="Arial" pitchFamily="34" charset="-122"/>
                 <a:cs typeface="Arial" pitchFamily="34" charset="-120"/>
               </a:rPr>
-              <a:t>€ 8,97 mln</a:t>
+              <a:t>€ 0,00 mln</a:t>
             </a:r>
             <a:endParaRPr lang="en-US" sz="3200" dirty="0"/>
           </a:p>
@@ -8173,7 +8173,7 @@
                 <a:ea typeface="Arial" pitchFamily="34" charset="-122"/>
                 <a:cs typeface="Arial" pitchFamily="34" charset="-120"/>
               </a:rPr>
-              <a:t>€ 17,93 mln</a:t>
+              <a:t>€ 0,00 mln</a:t>
             </a:r>
             <a:endParaRPr lang="en-US" sz="3200" dirty="0"/>
           </a:p>
@@ -8280,7 +8280,7 @@
                 <a:ea typeface="Arial" pitchFamily="34" charset="-122"/>
                 <a:cs typeface="Arial" pitchFamily="34" charset="-120"/>
               </a:rPr>
-              <a:t>5.977 wagens</a:t>
+              <a:t>0 wagens</a:t>
             </a:r>
             <a:pPr indent="0" marL="0">
               <a:buNone/>
@@ -8308,7 +8308,7 @@
                 <a:ea typeface="Arial" pitchFamily="34" charset="-122"/>
                 <a:cs typeface="Arial" pitchFamily="34" charset="-120"/>
               </a:rPr>
-              <a:t>€ 8,97 mln besparing / jaar</a:t>
+              <a:t>€ 0,00 mln besparing / jaar</a:t>
             </a:r>
             <a:endParaRPr lang="en-US" sz="1500" dirty="0"/>
           </a:p>
@@ -8347,7 +8347,7 @@
                 <a:ea typeface="Arial" pitchFamily="34" charset="-122"/>
                 <a:cs typeface="Arial" pitchFamily="34" charset="-120"/>
               </a:rPr>
-              <a:t>5.977 wagens</a:t>
+              <a:t>0 wagens</a:t>
             </a:r>
             <a:pPr indent="0" marL="0">
               <a:buNone/>
@@ -8375,7 +8375,7 @@
                 <a:ea typeface="Arial" pitchFamily="34" charset="-122"/>
                 <a:cs typeface="Arial" pitchFamily="34" charset="-120"/>
               </a:rPr>
-              <a:t>€ 17,93 mln investering</a:t>
+              <a:t>€ 0,00 mln investering</a:t>
             </a:r>
             <a:pPr indent="0" marL="0">
               <a:buNone/>
@@ -8721,7 +8721,7 @@
                 <a:ea typeface="Arial" pitchFamily="34" charset="-122"/>
                 <a:cs typeface="Arial" pitchFamily="34" charset="-120"/>
               </a:rPr>
-              <a:t>210 parkings · 5.977 plaatsen</a:t>
+              <a:t>0 parkings · 0 plaatsen</a:t>
             </a:r>
             <a:endParaRPr lang="en-US" sz="2200" dirty="0"/>
           </a:p>
@@ -10776,7 +10776,7 @@
                 <a:ea typeface="Arial" pitchFamily="34" charset="-122"/>
                 <a:cs typeface="Arial" pitchFamily="34" charset="-120"/>
               </a:rPr>
-              <a:t>5.977 auto’s op 210 slimme parkings in Lommel </a:t>
+              <a:t>0 auto’s op 0 slimme parkings in Lommel </a:t>
             </a:r>
             <a:pPr indent="0" marL="0">
               <a:lnSpc>
@@ -10793,7 +10793,7 @@
                 <a:ea typeface="Arial" pitchFamily="34" charset="-122"/>
                 <a:cs typeface="Arial" pitchFamily="34" charset="-120"/>
               </a:rPr>
-              <a:t>verhogen de loadfactor van 33% naar 64% en remmen de congestie af.</a:t>
+              <a:t>verhogen de loadfactor van 32% naar 32% en remmen de congestie af.</a:t>
             </a:r>
             <a:endParaRPr lang="en-US" sz="1400" dirty="0"/>
           </a:p>
@@ -10835,7 +10835,7 @@
                 <a:ea typeface="Arial" pitchFamily="34" charset="-122"/>
                 <a:cs typeface="Arial" pitchFamily="34" charset="-120"/>
               </a:rPr>
-              <a:t>* Loadfactor t.o.v. referentiestation: kopstation OVERP150 (150 kV), 6 km van Lommel (laagste load van de cluster &lt;5 km). · v6</a:t>
+              <a:t>* Loadfactor t.o.v. referentiestation: kopstation BALEN150 (150 kV), 5.1 km van Lommel. · v6</a:t>
             </a:r>
             <a:endParaRPr lang="en-US" sz="900" dirty="0"/>
           </a:p>
@@ -10980,7 +10980,7 @@
                 <a:ea typeface="Arial" pitchFamily="34" charset="-122"/>
                 <a:cs typeface="Arial" pitchFamily="34" charset="-120"/>
               </a:rPr>
-              <a:t>Loadfactor van station OVERP150 (150 kV) — dichtste kopstation bij Lommel, op ± 6 km (laagste load van de cluster &lt;5 km). Flex ≈ 35 MW (11 kW/wagen + 10 kW batterij) op 175 MW firm capacity.</a:t>
+              <a:t>Loadfactor van station BALEN150 (150 kV) — dichtste kopstation bij Lommel, op ± 5.1 km. Flex ≈ 0 MW (11 kW/wagen + 10 kW batterij) op 175 MW firm capacity.</a:t>
             </a:r>
             <a:endParaRPr lang="en-US" sz="900" dirty="0"/>
           </a:p>
@@ -11088,7 +11088,7 @@
                 <a:ea typeface="Arial" pitchFamily="34" charset="-122"/>
                 <a:cs typeface="Arial" pitchFamily="34" charset="-120"/>
               </a:rPr>
-              <a:t>+94%</a:t>
+              <a:t>+0%</a:t>
             </a:r>
             <a:pPr algn="ctr" indent="0" marL="0">
               <a:lnSpc>

</xml_diff>